<commit_message>
Add a pain killer slide and rename the impact ladder headings in the PPTX
The editable presentation now has six slides: a new "Wie optimiert Hivebuy
den Prozess" slide after the potenziale, the two ladder slides renamed to
"Vorteile für Bedarfsträger und den Einkauf" and "Vorteile für Finance &
Controlling und die Geschäftsführung", and the summary renamed to
"Zusammenfassung". The PDF template stays untouched.

Co-Authored-By: Claude Opus 5 <noreply@anthropic.com>
Claude-Session: https://claude.ai/code/session_012oWyUSWf5ZiJJNpmrjt8g8
</commit_message>
<xml_diff>
--- a/.claude/skills/impact-ladder-pdf/output/2026-08-20-impact-ladder-navax-software.pptx
+++ b/.claude/skills/impact-ladder-pdf/output/2026-08-20-impact-ladder-navax-software.pptx
@@ -10,6 +10,7 @@
     <p:sldId id="258" r:id="rId9"/>
     <p:sldId id="259" r:id="rId10"/>
     <p:sldId id="260" r:id="rId11"/>
+    <p:sldId id="261" r:id="rId12"/>
   </p:sldIdLst>
   <p:sldSz cx="12192120" cy="6858000" type="screen4x3"/>
   <p:notesSz cx="6858000" cy="9144000"/>
@@ -1828,7 +1829,7 @@
                 </a:solidFill>
                 <a:latin typeface="DM Sans"/>
               </a:rPr>
-              <a:t>IMPACT LADDER, EBENE 1 UND 2</a:t>
+              <a:t>WIE OPTIMIERT HIVEBUY DEN PROZESS</a:t>
             </a:r>
           </a:p>
         </p:txBody>
@@ -1927,69 +1928,14 @@
       </p:sp>
       <p:sp>
         <p:nvSpPr>
-          <p:cNvPr id="6" name="Rounded Rectangle 5"/>
-          <p:cNvSpPr/>
-          <p:nvPr/>
-        </p:nvSpPr>
-        <p:spPr>
-          <a:xfrm>
-            <a:off x="936000" y="1224000"/>
-            <a:ext cx="396000" cy="396000"/>
-          </a:xfrm>
-          <a:prstGeom prst="roundRect">
-            <a:avLst>
-              <a:gd name="adj" fmla="val 6000"/>
-            </a:avLst>
-          </a:prstGeom>
-          <a:solidFill>
-            <a:srgbClr val="204540"/>
-          </a:solidFill>
-          <a:ln>
-            <a:noFill/>
-          </a:ln>
-          <a:effectLst/>
-        </p:spPr>
-        <p:style>
-          <a:lnRef idx="1">
-            <a:schemeClr val="accent1"/>
-          </a:lnRef>
-          <a:fillRef idx="3">
-            <a:schemeClr val="accent1"/>
-          </a:fillRef>
-          <a:effectRef idx="2">
-            <a:schemeClr val="accent1"/>
-          </a:effectRef>
-          <a:fontRef idx="minor">
-            <a:schemeClr val="lt1"/>
-          </a:fontRef>
-        </p:style>
-        <p:txBody>
-          <a:bodyPr rtlCol="0" anchor="ctr" wrap="square"/>
-          <a:lstStyle/>
-          <a:p>
-            <a:pPr algn="ctr"/>
-            <a:r>
-              <a:rPr sz="1400" b="1">
-                <a:solidFill>
-                  <a:srgbClr val="F1FF45"/>
-                </a:solidFill>
-                <a:latin typeface="DM Sans"/>
-              </a:rPr>
-              <a:t>1</a:t>
-            </a:r>
-          </a:p>
-        </p:txBody>
-      </p:sp>
-      <p:sp>
-        <p:nvSpPr>
-          <p:cNvPr id="7" name="TextBox 6"/>
+          <p:cNvPr id="6" name="TextBox 5"/>
           <p:cNvSpPr txBox="1"/>
           <p:nvPr/>
         </p:nvSpPr>
         <p:spPr>
           <a:xfrm>
-            <a:off x="1440000" y="1260000"/>
-            <a:ext cx="4260060" cy="576000"/>
+            <a:off x="1008000" y="1296000"/>
+            <a:ext cx="4620060" cy="4662000"/>
           </a:xfrm>
           <a:prstGeom prst="rect">
             <a:avLst/>
@@ -2004,48 +1950,25 @@
           <a:p>
             <a:pPr>
               <a:lnSpc>
-                <a:spcPct val="110000"/>
-              </a:lnSpc>
-              <a:spcBef>
-                <a:spcPts val="0"/>
-              </a:spcBef>
-              <a:spcAft>
-                <a:spcPts val="0"/>
-              </a:spcAft>
-            </a:pPr>
-            <a:r>
-              <a:rPr sz="1700" b="0">
+                <a:spcPct val="130000"/>
+              </a:lnSpc>
+              <a:spcBef>
+                <a:spcPts val="0"/>
+              </a:spcBef>
+              <a:spcAft>
+                <a:spcPts val="900"/>
+              </a:spcAft>
+            </a:pPr>
+            <a:r>
+              <a:rPr sz="1300" b="0">
                 <a:solidFill>
                   <a:srgbClr val="204540"/>
                 </a:solidFill>
-                <a:latin typeface="Frank Ruhl Libre"/>
-              </a:rPr>
-              <a:t>Mitarbeitende / Bedarfsträger</a:t>
-            </a:r>
-          </a:p>
-        </p:txBody>
-      </p:sp>
-      <p:sp>
-        <p:nvSpPr>
-          <p:cNvPr id="8" name="TextBox 7"/>
-          <p:cNvSpPr txBox="1"/>
-          <p:nvPr/>
-        </p:nvSpPr>
-        <p:spPr>
-          <a:xfrm>
-            <a:off x="936000" y="1980000"/>
-            <a:ext cx="4764060" cy="3438000"/>
-          </a:xfrm>
-          <a:prstGeom prst="rect">
-            <a:avLst/>
-          </a:prstGeom>
-          <a:noFill/>
-        </p:spPr>
-        <p:txBody>
-          <a:bodyPr wrap="square" lIns="0" rIns="0" tIns="0" bIns="0">
-            <a:spAutoFit/>
-          </a:bodyPr>
-          <a:lstStyle/>
+                <a:latin typeface="DM Sans"/>
+              </a:rPr>
+              <a:t>•  Zentrale Plattform als erste Instanz für alle Bedarfsanforderungen, ersetzt die Jira-Tickets</a:t>
+            </a:r>
+          </a:p>
           <a:p>
             <a:pPr>
               <a:lnSpc>
@@ -2055,7 +1978,7 @@
                 <a:spcPts val="0"/>
               </a:spcBef>
               <a:spcAft>
-                <a:spcPts val="700"/>
+                <a:spcPts val="900"/>
               </a:spcAft>
             </a:pPr>
             <a:r>
@@ -2065,7 +1988,7 @@
                 </a:solidFill>
                 <a:latin typeface="DM Sans"/>
               </a:rPr>
-              <a:t>•  Bedarfe werden strukturiert und vollständig erfasst, statt als Jira-Ticket und E-Mail (Intake Agent).</a:t>
+              <a:t>•  Anforderung inklusive Kostenstelle, Warengruppe und Sachkonto direkt im System</a:t>
             </a:r>
           </a:p>
           <a:p>
@@ -2077,7 +2000,7 @@
                 <a:spcPts val="0"/>
               </a:spcBef>
               <a:spcAft>
-                <a:spcPts val="700"/>
+                <a:spcPts val="900"/>
               </a:spcAft>
             </a:pPr>
             <a:r>
@@ -2087,114 +2010,58 @@
                 </a:solidFill>
                 <a:latin typeface="DM Sans"/>
               </a:rPr>
-              <a:t>•  Anfragen und Freigaben laufen direkt in Microsoft Teams, der Status ist jederzeit sichtbar (MS Teams Agent, Status Agent).</a:t>
-            </a:r>
-          </a:p>
-        </p:txBody>
-      </p:sp>
-      <p:sp>
-        <p:nvSpPr>
-          <p:cNvPr id="9" name="Rounded Rectangle 8"/>
-          <p:cNvSpPr/>
-          <p:nvPr/>
-        </p:nvSpPr>
-        <p:spPr>
-          <a:xfrm>
-            <a:off x="936000" y="5490000"/>
-            <a:ext cx="792000" cy="252000"/>
-          </a:xfrm>
-          <a:prstGeom prst="roundRect">
-            <a:avLst>
-              <a:gd name="adj" fmla="val 6000"/>
-            </a:avLst>
-          </a:prstGeom>
-          <a:solidFill>
-            <a:srgbClr val="F1FF45"/>
-          </a:solidFill>
-          <a:ln>
-            <a:noFill/>
-          </a:ln>
-          <a:effectLst/>
-        </p:spPr>
-        <p:style>
-          <a:lnRef idx="1">
-            <a:schemeClr val="accent1"/>
-          </a:lnRef>
-          <a:fillRef idx="3">
-            <a:schemeClr val="accent1"/>
-          </a:fillRef>
-          <a:effectRef idx="2">
-            <a:schemeClr val="accent1"/>
-          </a:effectRef>
-          <a:fontRef idx="minor">
-            <a:schemeClr val="lt1"/>
-          </a:fontRef>
-        </p:style>
-        <p:txBody>
-          <a:bodyPr rtlCol="0" anchor="ctr" wrap="square"/>
-          <a:lstStyle/>
-          <a:p>
-            <a:pPr algn="ctr"/>
-            <a:r>
-              <a:rPr sz="900" b="1">
+              <a:t>•  Lieferanten zentral administriert: Webshops, Punch-out und Freitext für Einmalbedarfe</a:t>
+            </a:r>
+          </a:p>
+          <a:p>
+            <a:pPr>
+              <a:lnSpc>
+                <a:spcPct val="130000"/>
+              </a:lnSpc>
+              <a:spcBef>
+                <a:spcPts val="0"/>
+              </a:spcBef>
+              <a:spcAft>
+                <a:spcPts val="900"/>
+              </a:spcAft>
+            </a:pPr>
+            <a:r>
+              <a:rPr sz="1300" b="0">
                 <a:solidFill>
                   <a:srgbClr val="204540"/>
                 </a:solidFill>
                 <a:latin typeface="DM Sans"/>
               </a:rPr>
-              <a:t>IMPACT</a:t>
-            </a:r>
-          </a:p>
-        </p:txBody>
-      </p:sp>
-      <p:sp>
-        <p:nvSpPr>
-          <p:cNvPr id="10" name="TextBox 9"/>
-          <p:cNvSpPr txBox="1"/>
-          <p:nvPr/>
-        </p:nvSpPr>
-        <p:spPr>
-          <a:xfrm>
-            <a:off x="1836000" y="5472000"/>
-            <a:ext cx="3828060" cy="576000"/>
-          </a:xfrm>
-          <a:prstGeom prst="rect">
-            <a:avLst/>
-          </a:prstGeom>
-          <a:noFill/>
-        </p:spPr>
-        <p:txBody>
-          <a:bodyPr wrap="square" lIns="0" rIns="0" tIns="0" bIns="0">
-            <a:spAutoFit/>
-          </a:bodyPr>
-          <a:lstStyle/>
-          <a:p>
-            <a:pPr>
-              <a:lnSpc>
-                <a:spcPct val="125000"/>
-              </a:lnSpc>
-              <a:spcBef>
-                <a:spcPts val="0"/>
-              </a:spcBef>
-              <a:spcAft>
-                <a:spcPts val="0"/>
-              </a:spcAft>
-            </a:pPr>
-            <a:r>
-              <a:rPr sz="1200" b="1">
-                <a:solidFill>
-                  <a:srgbClr val="3E5B56"/>
-                </a:solidFill>
-                <a:latin typeface="DM Sans"/>
-              </a:rPr>
-              <a:t>Auch wer selten bestellt, findet den Weg ohne Schulung und ohne Rückfragen.</a:t>
-            </a:r>
-          </a:p>
-        </p:txBody>
-      </p:sp>
-      <p:sp>
-        <p:nvSpPr>
-          <p:cNvPr id="11" name="Rounded Rectangle 10"/>
+              <a:t>•  Digitaler Freigabeprozess mit vollständigem Audit-Trail</a:t>
+            </a:r>
+          </a:p>
+          <a:p>
+            <a:pPr>
+              <a:lnSpc>
+                <a:spcPct val="130000"/>
+              </a:lnSpc>
+              <a:spcBef>
+                <a:spcPts val="0"/>
+              </a:spcBef>
+              <a:spcAft>
+                <a:spcPts val="900"/>
+              </a:spcAft>
+            </a:pPr>
+            <a:r>
+              <a:rPr sz="1300" b="0">
+                <a:solidFill>
+                  <a:srgbClr val="204540"/>
+                </a:solidFill>
+                <a:latin typeface="DM Sans"/>
+              </a:rPr>
+              <a:t>•  Konfigurierbare Vertretungsregeln, Freigaben laufen auch im Urlaub weiter</a:t>
+            </a:r>
+          </a:p>
+        </p:txBody>
+      </p:sp>
+      <p:sp>
+        <p:nvSpPr>
+          <p:cNvPr id="7" name="Rounded Rectangle 6"/>
           <p:cNvSpPr/>
           <p:nvPr/>
         </p:nvSpPr>
@@ -2242,7 +2109,7 @@
       </p:sp>
       <p:sp>
         <p:nvSpPr>
-          <p:cNvPr id="12" name="Rectangle 11"/>
+          <p:cNvPr id="8" name="Rectangle 7"/>
           <p:cNvSpPr/>
           <p:nvPr/>
         </p:nvSpPr>
@@ -2286,69 +2153,14 @@
       </p:sp>
       <p:sp>
         <p:nvSpPr>
-          <p:cNvPr id="13" name="Rounded Rectangle 12"/>
-          <p:cNvSpPr/>
-          <p:nvPr/>
-        </p:nvSpPr>
-        <p:spPr>
-          <a:xfrm>
-            <a:off x="6492060" y="1224000"/>
-            <a:ext cx="396000" cy="396000"/>
-          </a:xfrm>
-          <a:prstGeom prst="roundRect">
-            <a:avLst>
-              <a:gd name="adj" fmla="val 6000"/>
-            </a:avLst>
-          </a:prstGeom>
-          <a:solidFill>
-            <a:srgbClr val="204540"/>
-          </a:solidFill>
-          <a:ln>
-            <a:noFill/>
-          </a:ln>
-          <a:effectLst/>
-        </p:spPr>
-        <p:style>
-          <a:lnRef idx="1">
-            <a:schemeClr val="accent1"/>
-          </a:lnRef>
-          <a:fillRef idx="3">
-            <a:schemeClr val="accent1"/>
-          </a:fillRef>
-          <a:effectRef idx="2">
-            <a:schemeClr val="accent1"/>
-          </a:effectRef>
-          <a:fontRef idx="minor">
-            <a:schemeClr val="lt1"/>
-          </a:fontRef>
-        </p:style>
-        <p:txBody>
-          <a:bodyPr rtlCol="0" anchor="ctr" wrap="square"/>
-          <a:lstStyle/>
-          <a:p>
-            <a:pPr algn="ctr"/>
-            <a:r>
-              <a:rPr sz="1400" b="1">
-                <a:solidFill>
-                  <a:srgbClr val="F1FF45"/>
-                </a:solidFill>
-                <a:latin typeface="DM Sans"/>
-              </a:rPr>
-              <a:t>2</a:t>
-            </a:r>
-          </a:p>
-        </p:txBody>
-      </p:sp>
-      <p:sp>
-        <p:nvSpPr>
-          <p:cNvPr id="14" name="TextBox 13"/>
+          <p:cNvPr id="9" name="TextBox 8"/>
           <p:cNvSpPr txBox="1"/>
           <p:nvPr/>
         </p:nvSpPr>
         <p:spPr>
           <a:xfrm>
-            <a:off x="6996060" y="1260000"/>
-            <a:ext cx="4260060" cy="576000"/>
+            <a:off x="6564060" y="1296000"/>
+            <a:ext cx="4620060" cy="4662000"/>
           </a:xfrm>
           <a:prstGeom prst="rect">
             <a:avLst/>
@@ -2363,48 +2175,25 @@
           <a:p>
             <a:pPr>
               <a:lnSpc>
-                <a:spcPct val="110000"/>
-              </a:lnSpc>
-              <a:spcBef>
-                <a:spcPts val="0"/>
-              </a:spcBef>
-              <a:spcAft>
-                <a:spcPts val="0"/>
-              </a:spcAft>
-            </a:pPr>
-            <a:r>
-              <a:rPr sz="1700" b="0">
+                <a:spcPct val="130000"/>
+              </a:lnSpc>
+              <a:spcBef>
+                <a:spcPts val="0"/>
+              </a:spcBef>
+              <a:spcAft>
+                <a:spcPts val="900"/>
+              </a:spcAft>
+            </a:pPr>
+            <a:r>
+              <a:rPr sz="1300" b="0">
                 <a:solidFill>
                   <a:srgbClr val="204540"/>
                 </a:solidFill>
-                <a:latin typeface="Frank Ruhl Libre"/>
-              </a:rPr>
-              <a:t>Einkauf / Administration</a:t>
-            </a:r>
-          </a:p>
-        </p:txBody>
-      </p:sp>
-      <p:sp>
-        <p:nvSpPr>
-          <p:cNvPr id="15" name="TextBox 14"/>
-          <p:cNvSpPr txBox="1"/>
-          <p:nvPr/>
-        </p:nvSpPr>
-        <p:spPr>
-          <a:xfrm>
-            <a:off x="6492060" y="1980000"/>
-            <a:ext cx="4764060" cy="3438000"/>
-          </a:xfrm>
-          <a:prstGeom prst="rect">
-            <a:avLst/>
-          </a:prstGeom>
-          <a:noFill/>
-        </p:spPr>
-        <p:txBody>
-          <a:bodyPr wrap="square" lIns="0" rIns="0" tIns="0" bIns="0">
-            <a:spAutoFit/>
-          </a:bodyPr>
-          <a:lstStyle/>
+                <a:latin typeface="DM Sans"/>
+              </a:rPr>
+              <a:t>•  Freigaben zusätzlich direkt in Microsoft Teams</a:t>
+            </a:r>
+          </a:p>
           <a:p>
             <a:pPr>
               <a:lnSpc>
@@ -2414,7 +2203,7 @@
                 <a:spcPts val="0"/>
               </a:spcBef>
               <a:spcAft>
-                <a:spcPts val="700"/>
+                <a:spcPts val="900"/>
               </a:spcAft>
             </a:pPr>
             <a:r>
@@ -2424,7 +2213,7 @@
                 </a:solidFill>
                 <a:latin typeface="DM Sans"/>
               </a:rPr>
-              <a:t>•  Freigaben regelbasiert nach Betrag, Warengruppe und Gesellschaft, mit konfigurierbarer Vertretung (Approval Agent).</a:t>
+              <a:t>•  Schnittstelle zu Business Central: Bestellungen im ERP, Rechnungen automatisch gematcht</a:t>
             </a:r>
           </a:p>
           <a:p>
@@ -2436,7 +2225,7 @@
                 <a:spcPts val="0"/>
               </a:spcBef>
               <a:spcAft>
-                <a:spcPts val="700"/>
+                <a:spcPts val="900"/>
               </a:spcAft>
             </a:pPr>
             <a:r>
@@ -2446,107 +2235,51 @@
                 </a:solidFill>
                 <a:latin typeface="DM Sans"/>
               </a:rPr>
-              <a:t>•  Verträge zentral hinterlegt, mit Erinnerung an Verlängerung und Kündigungsfrist (Contract Agent).</a:t>
-            </a:r>
-          </a:p>
-        </p:txBody>
-      </p:sp>
-      <p:sp>
-        <p:nvSpPr>
-          <p:cNvPr id="16" name="Rounded Rectangle 15"/>
-          <p:cNvSpPr/>
-          <p:nvPr/>
-        </p:nvSpPr>
-        <p:spPr>
-          <a:xfrm>
-            <a:off x="6492060" y="5490000"/>
-            <a:ext cx="792000" cy="252000"/>
-          </a:xfrm>
-          <a:prstGeom prst="roundRect">
-            <a:avLst>
-              <a:gd name="adj" fmla="val 6000"/>
-            </a:avLst>
-          </a:prstGeom>
-          <a:solidFill>
-            <a:srgbClr val="F1FF45"/>
-          </a:solidFill>
-          <a:ln>
-            <a:noFill/>
-          </a:ln>
-          <a:effectLst/>
-        </p:spPr>
-        <p:style>
-          <a:lnRef idx="1">
-            <a:schemeClr val="accent1"/>
-          </a:lnRef>
-          <a:fillRef idx="3">
-            <a:schemeClr val="accent1"/>
-          </a:fillRef>
-          <a:effectRef idx="2">
-            <a:schemeClr val="accent1"/>
-          </a:effectRef>
-          <a:fontRef idx="minor">
-            <a:schemeClr val="lt1"/>
-          </a:fontRef>
-        </p:style>
-        <p:txBody>
-          <a:bodyPr rtlCol="0" anchor="ctr" wrap="square"/>
-          <a:lstStyle/>
-          <a:p>
-            <a:pPr algn="ctr"/>
-            <a:r>
-              <a:rPr sz="900" b="1">
+              <a:t>•  Automatische Freigabe wiederkehrender, gleichbleibender Rechnungspositionen</a:t>
+            </a:r>
+          </a:p>
+          <a:p>
+            <a:pPr>
+              <a:lnSpc>
+                <a:spcPct val="130000"/>
+              </a:lnSpc>
+              <a:spcBef>
+                <a:spcPts val="0"/>
+              </a:spcBef>
+              <a:spcAft>
+                <a:spcPts val="900"/>
+              </a:spcAft>
+            </a:pPr>
+            <a:r>
+              <a:rPr sz="1300" b="0">
                 <a:solidFill>
                   <a:srgbClr val="204540"/>
                 </a:solidFill>
                 <a:latin typeface="DM Sans"/>
               </a:rPr>
-              <a:t>IMPACT</a:t>
-            </a:r>
-          </a:p>
-        </p:txBody>
-      </p:sp>
-      <p:sp>
-        <p:nvSpPr>
-          <p:cNvPr id="17" name="TextBox 16"/>
-          <p:cNvSpPr txBox="1"/>
-          <p:nvPr/>
-        </p:nvSpPr>
-        <p:spPr>
-          <a:xfrm>
-            <a:off x="7392060" y="5472000"/>
-            <a:ext cx="3828060" cy="576000"/>
-          </a:xfrm>
-          <a:prstGeom prst="rect">
-            <a:avLst/>
-          </a:prstGeom>
-          <a:noFill/>
-        </p:spPr>
-        <p:txBody>
-          <a:bodyPr wrap="square" lIns="0" rIns="0" tIns="0" bIns="0">
-            <a:spAutoFit/>
-          </a:bodyPr>
-          <a:lstStyle/>
-          <a:p>
-            <a:pPr>
-              <a:lnSpc>
-                <a:spcPct val="125000"/>
-              </a:lnSpc>
-              <a:spcBef>
-                <a:spcPts val="0"/>
-              </a:spcBef>
-              <a:spcAft>
-                <a:spcPts val="0"/>
-              </a:spcAft>
-            </a:pPr>
-            <a:r>
-              <a:rPr sz="1200" b="1">
-                <a:solidFill>
-                  <a:srgbClr val="3E5B56"/>
-                </a:solidFill>
-                <a:latin typeface="DM Sans"/>
-              </a:rPr>
-              <a:t>Die täglichen ein bis zwei Stunden Handarbeit entfallen, der Prozess läuft auch im Urlaub weiter.</a:t>
+              <a:t>•  SSO über Microsoft Active Directory, Deaktivierung wirkt sofort in Hivebuy</a:t>
+            </a:r>
+          </a:p>
+          <a:p>
+            <a:pPr>
+              <a:lnSpc>
+                <a:spcPct val="130000"/>
+              </a:lnSpc>
+              <a:spcBef>
+                <a:spcPts val="0"/>
+              </a:spcBef>
+              <a:spcAft>
+                <a:spcPts val="900"/>
+              </a:spcAft>
+            </a:pPr>
+            <a:r>
+              <a:rPr sz="1300" b="0">
+                <a:solidFill>
+                  <a:srgbClr val="204540"/>
+                </a:solidFill>
+                <a:latin typeface="DM Sans"/>
+              </a:rPr>
+              <a:t>•  Vertragsmanagement mit Katalogartikeln und Erinnerung an Verlängerung und Kündigungsfrist</a:t>
             </a:r>
           </a:p>
         </p:txBody>
@@ -2653,7 +2386,7 @@
                 </a:solidFill>
                 <a:latin typeface="DM Sans"/>
               </a:rPr>
-              <a:t>IMPACT LADDER, EBENE 3 UND 4</a:t>
+              <a:t>VORTEILE FÜR BEDARFSTRÄGER UND DEN EINKAUF</a:t>
             </a:r>
           </a:p>
         </p:txBody>
@@ -2800,7 +2533,7 @@
                 </a:solidFill>
                 <a:latin typeface="DM Sans"/>
               </a:rPr>
-              <a:t>3</a:t>
+              <a:t>1</a:t>
             </a:r>
           </a:p>
         </p:txBody>
@@ -2845,7 +2578,7 @@
                 </a:solidFill>
                 <a:latin typeface="Frank Ruhl Libre"/>
               </a:rPr>
-              <a:t>Finance / Controlling</a:t>
+              <a:t>Mitarbeitende / Bedarfsträger</a:t>
             </a:r>
           </a:p>
         </p:txBody>
@@ -2890,7 +2623,7 @@
                 </a:solidFill>
                 <a:latin typeface="DM Sans"/>
               </a:rPr>
-              <a:t>•  Kostenstelle, Warengruppe und Sachkonto werden bereits bei der Anforderung vorbelegt (Category Agent, Accounting Agent).</a:t>
+              <a:t>•  Bedarfe werden strukturiert und vollständig erfasst, statt als Jira-Ticket und E-Mail (Intake Agent).</a:t>
             </a:r>
           </a:p>
           <a:p>
@@ -2912,7 +2645,7 @@
                 </a:solidFill>
                 <a:latin typeface="DM Sans"/>
               </a:rPr>
-              <a:t>•  Bestellungen entstehen in Business Central, Rechnungen werden automatisch zugeordnet, wiederkehrende Positionen laufen ohne Handgriff (Invoice Agent).</a:t>
+              <a:t>•  Anfragen und Freigaben laufen direkt in Microsoft Teams, der Status ist jederzeit sichtbar (MS Teams Agent, Status Agent).</a:t>
             </a:r>
           </a:p>
         </p:txBody>
@@ -3012,7 +2745,7 @@
                 </a:solidFill>
                 <a:latin typeface="DM Sans"/>
               </a:rPr>
-              <a:t>Der Medienbruch zum ERP verschwindet, auch bei Rechnungen mit bis zu 300 Positionen.</a:t>
+              <a:t>Auch wer selten bestellt, findet den Weg ohne Schulung und ohne Rückfragen.</a:t>
             </a:r>
           </a:p>
         </p:txBody>
@@ -3159,7 +2892,7 @@
                 </a:solidFill>
                 <a:latin typeface="DM Sans"/>
               </a:rPr>
-              <a:t>4</a:t>
+              <a:t>2</a:t>
             </a:r>
           </a:p>
         </p:txBody>
@@ -3204,7 +2937,7 @@
                 </a:solidFill>
                 <a:latin typeface="Frank Ruhl Libre"/>
               </a:rPr>
-              <a:t>Geschäftsführung / Management</a:t>
+              <a:t>Einkauf / Administration</a:t>
             </a:r>
           </a:p>
         </p:txBody>
@@ -3249,7 +2982,7 @@
                 </a:solidFill>
                 <a:latin typeface="DM Sans"/>
               </a:rPr>
-              <a:t>•  Ein Standard und eine Auswertung über alle sieben Gesellschaften in Deutschland und Österreich (Analytics Agent).</a:t>
+              <a:t>•  Freigaben regelbasiert nach Betrag, Warengruppe und Gesellschaft, mit konfigurierbarer Vertretung (Approval Agent).</a:t>
             </a:r>
           </a:p>
           <a:p>
@@ -3271,7 +3004,7 @@
                 </a:solidFill>
                 <a:latin typeface="DM Sans"/>
               </a:rPr>
-              <a:t>•  Vollständiger Audit-Trail für ISO 27001, DSGVO und die Nachweispflichten im Bankenumfeld (Compliance Agent).</a:t>
+              <a:t>•  Verträge zentral hinterlegt, mit Erinnerung an Verlängerung und Kündigungsfrist (Contract Agent).</a:t>
             </a:r>
           </a:p>
         </p:txBody>
@@ -3371,7 +3104,7 @@
                 </a:solidFill>
                 <a:latin typeface="DM Sans"/>
               </a:rPr>
-              <a:t>Nachweise sind auf Knopfdruck belegbar, der Einkauf ist nicht länger von einer Person abhängig.</a:t>
+              <a:t>Die täglichen ein bis zwei Stunden Handarbeit entfallen, der Prozess läuft auch im Urlaub weiter.</a:t>
             </a:r>
           </a:p>
         </p:txBody>
@@ -3478,7 +3211,832 @@
                 </a:solidFill>
                 <a:latin typeface="DM Sans"/>
               </a:rPr>
-              <a:t>EXECUTIVE SUMMARY</a:t>
+              <a:t>VORTEILE FÜR FINANCE &amp; CONTROLLING UND DIE GESCHÄFTSFÜHRUNG</a:t>
+            </a:r>
+          </a:p>
+        </p:txBody>
+      </p:sp>
+      <p:sp>
+        <p:nvSpPr>
+          <p:cNvPr id="4" name="Rounded Rectangle 3"/>
+          <p:cNvSpPr/>
+          <p:nvPr/>
+        </p:nvSpPr>
+        <p:spPr>
+          <a:xfrm>
+            <a:off x="684000" y="972000"/>
+            <a:ext cx="5268060" cy="5310000"/>
+          </a:xfrm>
+          <a:prstGeom prst="roundRect">
+            <a:avLst>
+              <a:gd name="adj" fmla="val 6000"/>
+            </a:avLst>
+          </a:prstGeom>
+          <a:solidFill>
+            <a:srgbClr val="FFFFFF"/>
+          </a:solidFill>
+          <a:ln w="12700">
+            <a:solidFill>
+              <a:srgbClr val="E3E9E7"/>
+            </a:solidFill>
+          </a:ln>
+          <a:effectLst/>
+        </p:spPr>
+        <p:style>
+          <a:lnRef idx="1">
+            <a:schemeClr val="accent1"/>
+          </a:lnRef>
+          <a:fillRef idx="3">
+            <a:schemeClr val="accent1"/>
+          </a:fillRef>
+          <a:effectRef idx="2">
+            <a:schemeClr val="accent1"/>
+          </a:effectRef>
+          <a:fontRef idx="minor">
+            <a:schemeClr val="lt1"/>
+          </a:fontRef>
+        </p:style>
+        <p:txBody>
+          <a:bodyPr rtlCol="0" anchor="ctr" wrap="square"/>
+          <a:lstStyle/>
+          <a:p>
+            <a:pPr algn="ctr"/>
+          </a:p>
+        </p:txBody>
+      </p:sp>
+      <p:sp>
+        <p:nvSpPr>
+          <p:cNvPr id="5" name="Rectangle 4"/>
+          <p:cNvSpPr/>
+          <p:nvPr/>
+        </p:nvSpPr>
+        <p:spPr>
+          <a:xfrm>
+            <a:off x="684000" y="972000"/>
+            <a:ext cx="57600" cy="5310000"/>
+          </a:xfrm>
+          <a:prstGeom prst="rect">
+            <a:avLst/>
+          </a:prstGeom>
+          <a:solidFill>
+            <a:srgbClr val="228C7D"/>
+          </a:solidFill>
+          <a:ln>
+            <a:noFill/>
+          </a:ln>
+          <a:effectLst/>
+        </p:spPr>
+        <p:style>
+          <a:lnRef idx="1">
+            <a:schemeClr val="accent1"/>
+          </a:lnRef>
+          <a:fillRef idx="3">
+            <a:schemeClr val="accent1"/>
+          </a:fillRef>
+          <a:effectRef idx="2">
+            <a:schemeClr val="accent1"/>
+          </a:effectRef>
+          <a:fontRef idx="minor">
+            <a:schemeClr val="lt1"/>
+          </a:fontRef>
+        </p:style>
+        <p:txBody>
+          <a:bodyPr rtlCol="0" anchor="ctr"/>
+          <a:lstStyle/>
+          <a:p>
+            <a:pPr algn="ctr"/>
+          </a:p>
+        </p:txBody>
+      </p:sp>
+      <p:sp>
+        <p:nvSpPr>
+          <p:cNvPr id="6" name="Rounded Rectangle 5"/>
+          <p:cNvSpPr/>
+          <p:nvPr/>
+        </p:nvSpPr>
+        <p:spPr>
+          <a:xfrm>
+            <a:off x="936000" y="1224000"/>
+            <a:ext cx="396000" cy="396000"/>
+          </a:xfrm>
+          <a:prstGeom prst="roundRect">
+            <a:avLst>
+              <a:gd name="adj" fmla="val 6000"/>
+            </a:avLst>
+          </a:prstGeom>
+          <a:solidFill>
+            <a:srgbClr val="204540"/>
+          </a:solidFill>
+          <a:ln>
+            <a:noFill/>
+          </a:ln>
+          <a:effectLst/>
+        </p:spPr>
+        <p:style>
+          <a:lnRef idx="1">
+            <a:schemeClr val="accent1"/>
+          </a:lnRef>
+          <a:fillRef idx="3">
+            <a:schemeClr val="accent1"/>
+          </a:fillRef>
+          <a:effectRef idx="2">
+            <a:schemeClr val="accent1"/>
+          </a:effectRef>
+          <a:fontRef idx="minor">
+            <a:schemeClr val="lt1"/>
+          </a:fontRef>
+        </p:style>
+        <p:txBody>
+          <a:bodyPr rtlCol="0" anchor="ctr" wrap="square"/>
+          <a:lstStyle/>
+          <a:p>
+            <a:pPr algn="ctr"/>
+            <a:r>
+              <a:rPr sz="1400" b="1">
+                <a:solidFill>
+                  <a:srgbClr val="F1FF45"/>
+                </a:solidFill>
+                <a:latin typeface="DM Sans"/>
+              </a:rPr>
+              <a:t>3</a:t>
+            </a:r>
+          </a:p>
+        </p:txBody>
+      </p:sp>
+      <p:sp>
+        <p:nvSpPr>
+          <p:cNvPr id="7" name="TextBox 6"/>
+          <p:cNvSpPr txBox="1"/>
+          <p:nvPr/>
+        </p:nvSpPr>
+        <p:spPr>
+          <a:xfrm>
+            <a:off x="1440000" y="1260000"/>
+            <a:ext cx="4260060" cy="576000"/>
+          </a:xfrm>
+          <a:prstGeom prst="rect">
+            <a:avLst/>
+          </a:prstGeom>
+          <a:noFill/>
+        </p:spPr>
+        <p:txBody>
+          <a:bodyPr wrap="square" lIns="0" rIns="0" tIns="0" bIns="0">
+            <a:spAutoFit/>
+          </a:bodyPr>
+          <a:lstStyle/>
+          <a:p>
+            <a:pPr>
+              <a:lnSpc>
+                <a:spcPct val="110000"/>
+              </a:lnSpc>
+              <a:spcBef>
+                <a:spcPts val="0"/>
+              </a:spcBef>
+              <a:spcAft>
+                <a:spcPts val="0"/>
+              </a:spcAft>
+            </a:pPr>
+            <a:r>
+              <a:rPr sz="1700" b="0">
+                <a:solidFill>
+                  <a:srgbClr val="204540"/>
+                </a:solidFill>
+                <a:latin typeface="Frank Ruhl Libre"/>
+              </a:rPr>
+              <a:t>Finance / Controlling</a:t>
+            </a:r>
+          </a:p>
+        </p:txBody>
+      </p:sp>
+      <p:sp>
+        <p:nvSpPr>
+          <p:cNvPr id="8" name="TextBox 7"/>
+          <p:cNvSpPr txBox="1"/>
+          <p:nvPr/>
+        </p:nvSpPr>
+        <p:spPr>
+          <a:xfrm>
+            <a:off x="936000" y="1980000"/>
+            <a:ext cx="4764060" cy="3438000"/>
+          </a:xfrm>
+          <a:prstGeom prst="rect">
+            <a:avLst/>
+          </a:prstGeom>
+          <a:noFill/>
+        </p:spPr>
+        <p:txBody>
+          <a:bodyPr wrap="square" lIns="0" rIns="0" tIns="0" bIns="0">
+            <a:spAutoFit/>
+          </a:bodyPr>
+          <a:lstStyle/>
+          <a:p>
+            <a:pPr>
+              <a:lnSpc>
+                <a:spcPct val="130000"/>
+              </a:lnSpc>
+              <a:spcBef>
+                <a:spcPts val="0"/>
+              </a:spcBef>
+              <a:spcAft>
+                <a:spcPts val="700"/>
+              </a:spcAft>
+            </a:pPr>
+            <a:r>
+              <a:rPr sz="1300" b="0">
+                <a:solidFill>
+                  <a:srgbClr val="204540"/>
+                </a:solidFill>
+                <a:latin typeface="DM Sans"/>
+              </a:rPr>
+              <a:t>•  Kostenstelle, Warengruppe und Sachkonto werden bereits bei der Anforderung vorbelegt (Category Agent, Accounting Agent).</a:t>
+            </a:r>
+          </a:p>
+          <a:p>
+            <a:pPr>
+              <a:lnSpc>
+                <a:spcPct val="130000"/>
+              </a:lnSpc>
+              <a:spcBef>
+                <a:spcPts val="0"/>
+              </a:spcBef>
+              <a:spcAft>
+                <a:spcPts val="700"/>
+              </a:spcAft>
+            </a:pPr>
+            <a:r>
+              <a:rPr sz="1300" b="0">
+                <a:solidFill>
+                  <a:srgbClr val="204540"/>
+                </a:solidFill>
+                <a:latin typeface="DM Sans"/>
+              </a:rPr>
+              <a:t>•  Bestellungen entstehen in Business Central, Rechnungen werden automatisch zugeordnet, wiederkehrende Positionen laufen ohne Handgriff (Invoice Agent).</a:t>
+            </a:r>
+          </a:p>
+        </p:txBody>
+      </p:sp>
+      <p:sp>
+        <p:nvSpPr>
+          <p:cNvPr id="9" name="Rounded Rectangle 8"/>
+          <p:cNvSpPr/>
+          <p:nvPr/>
+        </p:nvSpPr>
+        <p:spPr>
+          <a:xfrm>
+            <a:off x="936000" y="5490000"/>
+            <a:ext cx="792000" cy="252000"/>
+          </a:xfrm>
+          <a:prstGeom prst="roundRect">
+            <a:avLst>
+              <a:gd name="adj" fmla="val 6000"/>
+            </a:avLst>
+          </a:prstGeom>
+          <a:solidFill>
+            <a:srgbClr val="F1FF45"/>
+          </a:solidFill>
+          <a:ln>
+            <a:noFill/>
+          </a:ln>
+          <a:effectLst/>
+        </p:spPr>
+        <p:style>
+          <a:lnRef idx="1">
+            <a:schemeClr val="accent1"/>
+          </a:lnRef>
+          <a:fillRef idx="3">
+            <a:schemeClr val="accent1"/>
+          </a:fillRef>
+          <a:effectRef idx="2">
+            <a:schemeClr val="accent1"/>
+          </a:effectRef>
+          <a:fontRef idx="minor">
+            <a:schemeClr val="lt1"/>
+          </a:fontRef>
+        </p:style>
+        <p:txBody>
+          <a:bodyPr rtlCol="0" anchor="ctr" wrap="square"/>
+          <a:lstStyle/>
+          <a:p>
+            <a:pPr algn="ctr"/>
+            <a:r>
+              <a:rPr sz="900" b="1">
+                <a:solidFill>
+                  <a:srgbClr val="204540"/>
+                </a:solidFill>
+                <a:latin typeface="DM Sans"/>
+              </a:rPr>
+              <a:t>IMPACT</a:t>
+            </a:r>
+          </a:p>
+        </p:txBody>
+      </p:sp>
+      <p:sp>
+        <p:nvSpPr>
+          <p:cNvPr id="10" name="TextBox 9"/>
+          <p:cNvSpPr txBox="1"/>
+          <p:nvPr/>
+        </p:nvSpPr>
+        <p:spPr>
+          <a:xfrm>
+            <a:off x="1836000" y="5472000"/>
+            <a:ext cx="3828060" cy="576000"/>
+          </a:xfrm>
+          <a:prstGeom prst="rect">
+            <a:avLst/>
+          </a:prstGeom>
+          <a:noFill/>
+        </p:spPr>
+        <p:txBody>
+          <a:bodyPr wrap="square" lIns="0" rIns="0" tIns="0" bIns="0">
+            <a:spAutoFit/>
+          </a:bodyPr>
+          <a:lstStyle/>
+          <a:p>
+            <a:pPr>
+              <a:lnSpc>
+                <a:spcPct val="125000"/>
+              </a:lnSpc>
+              <a:spcBef>
+                <a:spcPts val="0"/>
+              </a:spcBef>
+              <a:spcAft>
+                <a:spcPts val="0"/>
+              </a:spcAft>
+            </a:pPr>
+            <a:r>
+              <a:rPr sz="1200" b="1">
+                <a:solidFill>
+                  <a:srgbClr val="3E5B56"/>
+                </a:solidFill>
+                <a:latin typeface="DM Sans"/>
+              </a:rPr>
+              <a:t>Der Medienbruch zum ERP verschwindet, auch bei Rechnungen mit bis zu 300 Positionen.</a:t>
+            </a:r>
+          </a:p>
+        </p:txBody>
+      </p:sp>
+      <p:sp>
+        <p:nvSpPr>
+          <p:cNvPr id="11" name="Rounded Rectangle 10"/>
+          <p:cNvSpPr/>
+          <p:nvPr/>
+        </p:nvSpPr>
+        <p:spPr>
+          <a:xfrm>
+            <a:off x="6240060" y="972000"/>
+            <a:ext cx="5268060" cy="5310000"/>
+          </a:xfrm>
+          <a:prstGeom prst="roundRect">
+            <a:avLst>
+              <a:gd name="adj" fmla="val 6000"/>
+            </a:avLst>
+          </a:prstGeom>
+          <a:solidFill>
+            <a:srgbClr val="FFFFFF"/>
+          </a:solidFill>
+          <a:ln w="12700">
+            <a:solidFill>
+              <a:srgbClr val="E3E9E7"/>
+            </a:solidFill>
+          </a:ln>
+          <a:effectLst/>
+        </p:spPr>
+        <p:style>
+          <a:lnRef idx="1">
+            <a:schemeClr val="accent1"/>
+          </a:lnRef>
+          <a:fillRef idx="3">
+            <a:schemeClr val="accent1"/>
+          </a:fillRef>
+          <a:effectRef idx="2">
+            <a:schemeClr val="accent1"/>
+          </a:effectRef>
+          <a:fontRef idx="minor">
+            <a:schemeClr val="lt1"/>
+          </a:fontRef>
+        </p:style>
+        <p:txBody>
+          <a:bodyPr rtlCol="0" anchor="ctr" wrap="square"/>
+          <a:lstStyle/>
+          <a:p>
+            <a:pPr algn="ctr"/>
+          </a:p>
+        </p:txBody>
+      </p:sp>
+      <p:sp>
+        <p:nvSpPr>
+          <p:cNvPr id="12" name="Rectangle 11"/>
+          <p:cNvSpPr/>
+          <p:nvPr/>
+        </p:nvSpPr>
+        <p:spPr>
+          <a:xfrm>
+            <a:off x="6240060" y="972000"/>
+            <a:ext cx="57600" cy="5310000"/>
+          </a:xfrm>
+          <a:prstGeom prst="rect">
+            <a:avLst/>
+          </a:prstGeom>
+          <a:solidFill>
+            <a:srgbClr val="228C7D"/>
+          </a:solidFill>
+          <a:ln>
+            <a:noFill/>
+          </a:ln>
+          <a:effectLst/>
+        </p:spPr>
+        <p:style>
+          <a:lnRef idx="1">
+            <a:schemeClr val="accent1"/>
+          </a:lnRef>
+          <a:fillRef idx="3">
+            <a:schemeClr val="accent1"/>
+          </a:fillRef>
+          <a:effectRef idx="2">
+            <a:schemeClr val="accent1"/>
+          </a:effectRef>
+          <a:fontRef idx="minor">
+            <a:schemeClr val="lt1"/>
+          </a:fontRef>
+        </p:style>
+        <p:txBody>
+          <a:bodyPr rtlCol="0" anchor="ctr"/>
+          <a:lstStyle/>
+          <a:p>
+            <a:pPr algn="ctr"/>
+          </a:p>
+        </p:txBody>
+      </p:sp>
+      <p:sp>
+        <p:nvSpPr>
+          <p:cNvPr id="13" name="Rounded Rectangle 12"/>
+          <p:cNvSpPr/>
+          <p:nvPr/>
+        </p:nvSpPr>
+        <p:spPr>
+          <a:xfrm>
+            <a:off x="6492060" y="1224000"/>
+            <a:ext cx="396000" cy="396000"/>
+          </a:xfrm>
+          <a:prstGeom prst="roundRect">
+            <a:avLst>
+              <a:gd name="adj" fmla="val 6000"/>
+            </a:avLst>
+          </a:prstGeom>
+          <a:solidFill>
+            <a:srgbClr val="204540"/>
+          </a:solidFill>
+          <a:ln>
+            <a:noFill/>
+          </a:ln>
+          <a:effectLst/>
+        </p:spPr>
+        <p:style>
+          <a:lnRef idx="1">
+            <a:schemeClr val="accent1"/>
+          </a:lnRef>
+          <a:fillRef idx="3">
+            <a:schemeClr val="accent1"/>
+          </a:fillRef>
+          <a:effectRef idx="2">
+            <a:schemeClr val="accent1"/>
+          </a:effectRef>
+          <a:fontRef idx="minor">
+            <a:schemeClr val="lt1"/>
+          </a:fontRef>
+        </p:style>
+        <p:txBody>
+          <a:bodyPr rtlCol="0" anchor="ctr" wrap="square"/>
+          <a:lstStyle/>
+          <a:p>
+            <a:pPr algn="ctr"/>
+            <a:r>
+              <a:rPr sz="1400" b="1">
+                <a:solidFill>
+                  <a:srgbClr val="F1FF45"/>
+                </a:solidFill>
+                <a:latin typeface="DM Sans"/>
+              </a:rPr>
+              <a:t>4</a:t>
+            </a:r>
+          </a:p>
+        </p:txBody>
+      </p:sp>
+      <p:sp>
+        <p:nvSpPr>
+          <p:cNvPr id="14" name="TextBox 13"/>
+          <p:cNvSpPr txBox="1"/>
+          <p:nvPr/>
+        </p:nvSpPr>
+        <p:spPr>
+          <a:xfrm>
+            <a:off x="6996060" y="1260000"/>
+            <a:ext cx="4260060" cy="576000"/>
+          </a:xfrm>
+          <a:prstGeom prst="rect">
+            <a:avLst/>
+          </a:prstGeom>
+          <a:noFill/>
+        </p:spPr>
+        <p:txBody>
+          <a:bodyPr wrap="square" lIns="0" rIns="0" tIns="0" bIns="0">
+            <a:spAutoFit/>
+          </a:bodyPr>
+          <a:lstStyle/>
+          <a:p>
+            <a:pPr>
+              <a:lnSpc>
+                <a:spcPct val="110000"/>
+              </a:lnSpc>
+              <a:spcBef>
+                <a:spcPts val="0"/>
+              </a:spcBef>
+              <a:spcAft>
+                <a:spcPts val="0"/>
+              </a:spcAft>
+            </a:pPr>
+            <a:r>
+              <a:rPr sz="1700" b="0">
+                <a:solidFill>
+                  <a:srgbClr val="204540"/>
+                </a:solidFill>
+                <a:latin typeface="Frank Ruhl Libre"/>
+              </a:rPr>
+              <a:t>Geschäftsführung / Management</a:t>
+            </a:r>
+          </a:p>
+        </p:txBody>
+      </p:sp>
+      <p:sp>
+        <p:nvSpPr>
+          <p:cNvPr id="15" name="TextBox 14"/>
+          <p:cNvSpPr txBox="1"/>
+          <p:nvPr/>
+        </p:nvSpPr>
+        <p:spPr>
+          <a:xfrm>
+            <a:off x="6492060" y="1980000"/>
+            <a:ext cx="4764060" cy="3438000"/>
+          </a:xfrm>
+          <a:prstGeom prst="rect">
+            <a:avLst/>
+          </a:prstGeom>
+          <a:noFill/>
+        </p:spPr>
+        <p:txBody>
+          <a:bodyPr wrap="square" lIns="0" rIns="0" tIns="0" bIns="0">
+            <a:spAutoFit/>
+          </a:bodyPr>
+          <a:lstStyle/>
+          <a:p>
+            <a:pPr>
+              <a:lnSpc>
+                <a:spcPct val="130000"/>
+              </a:lnSpc>
+              <a:spcBef>
+                <a:spcPts val="0"/>
+              </a:spcBef>
+              <a:spcAft>
+                <a:spcPts val="700"/>
+              </a:spcAft>
+            </a:pPr>
+            <a:r>
+              <a:rPr sz="1300" b="0">
+                <a:solidFill>
+                  <a:srgbClr val="204540"/>
+                </a:solidFill>
+                <a:latin typeface="DM Sans"/>
+              </a:rPr>
+              <a:t>•  Ein Standard und eine Auswertung über alle sieben Gesellschaften in Deutschland und Österreich (Analytics Agent).</a:t>
+            </a:r>
+          </a:p>
+          <a:p>
+            <a:pPr>
+              <a:lnSpc>
+                <a:spcPct val="130000"/>
+              </a:lnSpc>
+              <a:spcBef>
+                <a:spcPts val="0"/>
+              </a:spcBef>
+              <a:spcAft>
+                <a:spcPts val="700"/>
+              </a:spcAft>
+            </a:pPr>
+            <a:r>
+              <a:rPr sz="1300" b="0">
+                <a:solidFill>
+                  <a:srgbClr val="204540"/>
+                </a:solidFill>
+                <a:latin typeface="DM Sans"/>
+              </a:rPr>
+              <a:t>•  Vollständiger Audit-Trail für ISO 27001, DSGVO und die Nachweispflichten im Bankenumfeld (Compliance Agent).</a:t>
+            </a:r>
+          </a:p>
+        </p:txBody>
+      </p:sp>
+      <p:sp>
+        <p:nvSpPr>
+          <p:cNvPr id="16" name="Rounded Rectangle 15"/>
+          <p:cNvSpPr/>
+          <p:nvPr/>
+        </p:nvSpPr>
+        <p:spPr>
+          <a:xfrm>
+            <a:off x="6492060" y="5490000"/>
+            <a:ext cx="792000" cy="252000"/>
+          </a:xfrm>
+          <a:prstGeom prst="roundRect">
+            <a:avLst>
+              <a:gd name="adj" fmla="val 6000"/>
+            </a:avLst>
+          </a:prstGeom>
+          <a:solidFill>
+            <a:srgbClr val="F1FF45"/>
+          </a:solidFill>
+          <a:ln>
+            <a:noFill/>
+          </a:ln>
+          <a:effectLst/>
+        </p:spPr>
+        <p:style>
+          <a:lnRef idx="1">
+            <a:schemeClr val="accent1"/>
+          </a:lnRef>
+          <a:fillRef idx="3">
+            <a:schemeClr val="accent1"/>
+          </a:fillRef>
+          <a:effectRef idx="2">
+            <a:schemeClr val="accent1"/>
+          </a:effectRef>
+          <a:fontRef idx="minor">
+            <a:schemeClr val="lt1"/>
+          </a:fontRef>
+        </p:style>
+        <p:txBody>
+          <a:bodyPr rtlCol="0" anchor="ctr" wrap="square"/>
+          <a:lstStyle/>
+          <a:p>
+            <a:pPr algn="ctr"/>
+            <a:r>
+              <a:rPr sz="900" b="1">
+                <a:solidFill>
+                  <a:srgbClr val="204540"/>
+                </a:solidFill>
+                <a:latin typeface="DM Sans"/>
+              </a:rPr>
+              <a:t>IMPACT</a:t>
+            </a:r>
+          </a:p>
+        </p:txBody>
+      </p:sp>
+      <p:sp>
+        <p:nvSpPr>
+          <p:cNvPr id="17" name="TextBox 16"/>
+          <p:cNvSpPr txBox="1"/>
+          <p:nvPr/>
+        </p:nvSpPr>
+        <p:spPr>
+          <a:xfrm>
+            <a:off x="7392060" y="5472000"/>
+            <a:ext cx="3828060" cy="576000"/>
+          </a:xfrm>
+          <a:prstGeom prst="rect">
+            <a:avLst/>
+          </a:prstGeom>
+          <a:noFill/>
+        </p:spPr>
+        <p:txBody>
+          <a:bodyPr wrap="square" lIns="0" rIns="0" tIns="0" bIns="0">
+            <a:spAutoFit/>
+          </a:bodyPr>
+          <a:lstStyle/>
+          <a:p>
+            <a:pPr>
+              <a:lnSpc>
+                <a:spcPct val="125000"/>
+              </a:lnSpc>
+              <a:spcBef>
+                <a:spcPts val="0"/>
+              </a:spcBef>
+              <a:spcAft>
+                <a:spcPts val="0"/>
+              </a:spcAft>
+            </a:pPr>
+            <a:r>
+              <a:rPr sz="1200" b="1">
+                <a:solidFill>
+                  <a:srgbClr val="3E5B56"/>
+                </a:solidFill>
+                <a:latin typeface="DM Sans"/>
+              </a:rPr>
+              <a:t>Nachweise sind auf Knopfdruck belegbar, der Einkauf ist nicht länger von einer Person abhängig.</a:t>
+            </a:r>
+          </a:p>
+        </p:txBody>
+      </p:sp>
+    </p:spTree>
+  </p:cSld>
+  <p:clrMapOvr>
+    <a:masterClrMapping/>
+  </p:clrMapOvr>
+</p:sld>
+</file>
+
+<file path=ppt/slides/slide6.xml><?xml version="1.0" encoding="utf-8"?>
+<p:sld xmlns:a="http://schemas.openxmlformats.org/drawingml/2006/main" xmlns:p="http://schemas.openxmlformats.org/presentationml/2006/main" xmlns:r="http://schemas.openxmlformats.org/officeDocument/2006/relationships">
+  <p:cSld>
+    <p:spTree>
+      <p:nvGrpSpPr>
+        <p:cNvPr id="1" name=""/>
+        <p:cNvGrpSpPr/>
+        <p:nvPr/>
+      </p:nvGrpSpPr>
+      <p:grpSpPr/>
+      <p:sp>
+        <p:nvSpPr>
+          <p:cNvPr id="2" name="Rectangle 1"/>
+          <p:cNvSpPr/>
+          <p:nvPr/>
+        </p:nvSpPr>
+        <p:spPr>
+          <a:xfrm>
+            <a:off x="0" y="0"/>
+            <a:ext cx="12192120" cy="6858000"/>
+          </a:xfrm>
+          <a:prstGeom prst="rect">
+            <a:avLst/>
+          </a:prstGeom>
+          <a:solidFill>
+            <a:srgbClr val="FBFBFB"/>
+          </a:solidFill>
+          <a:ln>
+            <a:noFill/>
+          </a:ln>
+          <a:effectLst/>
+        </p:spPr>
+        <p:style>
+          <a:lnRef idx="1">
+            <a:schemeClr val="accent1"/>
+          </a:lnRef>
+          <a:fillRef idx="3">
+            <a:schemeClr val="accent1"/>
+          </a:fillRef>
+          <a:effectRef idx="2">
+            <a:schemeClr val="accent1"/>
+          </a:effectRef>
+          <a:fontRef idx="minor">
+            <a:schemeClr val="lt1"/>
+          </a:fontRef>
+        </p:style>
+        <p:txBody>
+          <a:bodyPr rtlCol="0" anchor="ctr"/>
+          <a:lstStyle/>
+          <a:p>
+            <a:pPr algn="ctr"/>
+          </a:p>
+        </p:txBody>
+      </p:sp>
+      <p:sp>
+        <p:nvSpPr>
+          <p:cNvPr id="3" name="TextBox 2"/>
+          <p:cNvSpPr txBox="1"/>
+          <p:nvPr/>
+        </p:nvSpPr>
+        <p:spPr>
+          <a:xfrm>
+            <a:off x="684000" y="576000"/>
+            <a:ext cx="10824120" cy="288000"/>
+          </a:xfrm>
+          <a:prstGeom prst="rect">
+            <a:avLst/>
+          </a:prstGeom>
+          <a:noFill/>
+        </p:spPr>
+        <p:txBody>
+          <a:bodyPr wrap="square" lIns="0" rIns="0" tIns="0" bIns="0">
+            <a:spAutoFit/>
+          </a:bodyPr>
+          <a:lstStyle/>
+          <a:p>
+            <a:pPr>
+              <a:lnSpc>
+                <a:spcPct val="125000"/>
+              </a:lnSpc>
+              <a:spcBef>
+                <a:spcPts val="0"/>
+              </a:spcBef>
+              <a:spcAft>
+                <a:spcPts val="0"/>
+              </a:spcAft>
+            </a:pPr>
+            <a:r>
+              <a:rPr sz="1200" b="1">
+                <a:solidFill>
+                  <a:srgbClr val="228C7D"/>
+                </a:solidFill>
+                <a:latin typeface="DM Sans"/>
+              </a:rPr>
+              <a:t>ZUSAMMENFASSUNG</a:t>
             </a:r>
           </a:p>
         </p:txBody>

</xml_diff>